<commit_message>
Document live app usage
</commit_message>
<xml_diff>
--- a/docs/Python_QA_Assistant_Slide_Deck.pptx
+++ b/docs/Python_QA_Assistant_Slide_Deck.pptx
@@ -2481,7 +2481,7 @@
                 <a:ea typeface="Aptos Display" pitchFamily="34" charset="-122"/>
                 <a:cs typeface="Aptos Display" pitchFamily="34" charset="-120"/>
               </a:rPr>
-              <a:t>10. Deployment Plan</a:t>
+              <a:t>10. Deployment</a:t>
             </a:r>
             <a:endParaRPr lang="en-US" sz="3000" dirty="0"/>
           </a:p>
@@ -2517,7 +2517,7 @@
                   <a:srgbClr val="475569"/>
                 </a:solidFill>
               </a:rPr>
-              <a:t>A simple public deployment path for the FastAPI service.</a:t>
+              <a:t>Public Render deployment for the FastAPI service.</a:t>
             </a:r>
             <a:endParaRPr lang="en-US" sz="1300" dirty="0"/>
           </a:p>
@@ -2751,7 +2751,7 @@
                   <a:srgbClr val="111827"/>
                 </a:solidFill>
               </a:rPr>
-              <a:t>Deploy on Hugging Face Spaces or Render free tier.</a:t>
+              <a:t>Deployed on Render free tier.</a:t>
             </a:r>
             <a:endParaRPr lang="en-US" sz="1800" dirty="0"/>
           </a:p>
@@ -2850,7 +2850,7 @@
                   <a:srgbClr val="111827"/>
                 </a:solidFill>
               </a:rPr>
-              <a:t>Start command: uvicorn app.main:app --host 0.0.0.0 --port $PORT.</a:t>
+              <a:t>Live URL: https://python-qa-rag-assistant.onrender.com</a:t>
             </a:r>
             <a:endParaRPr lang="en-US" sz="1800" dirty="0"/>
           </a:p>
@@ -2949,7 +2949,7 @@
                   <a:srgbClr val="111827"/>
                 </a:solidFill>
               </a:rPr>
-              <a:t>Set DATASET_PATH=data/processed_python_qa_5k.csv.</a:t>
+              <a:t>Swagger UI: https://python-qa-rag-assistant.onrender.com/docs</a:t>
             </a:r>
             <a:endParaRPr lang="en-US" sz="1800" dirty="0"/>
           </a:p>
@@ -3048,7 +3048,7 @@
                   <a:srgbClr val="111827"/>
                 </a:solidFill>
               </a:rPr>
-              <a:t>Add the live deployed URL to README.md after deployment.</a:t>
+              <a:t>Health check confirms document_count = 5000.</a:t>
             </a:r>
             <a:endParaRPr lang="en-US" sz="1800" dirty="0"/>
           </a:p>
@@ -3111,7 +3111,7 @@
                   <a:srgbClr val="FFFFFF"/>
                 </a:solidFill>
               </a:rPr>
-              <a:t>Deployment output: a public URL + README link for reviewers</a:t>
+              <a:t>Deployment output: public API URL + Swagger documentation</a:t>
             </a:r>
             <a:endParaRPr lang="en-US" sz="1350" dirty="0"/>
           </a:p>

</xml_diff>